<commit_message>
slides: add schematic figures to the gate-implementation deck
Draw four matplotlib schematics (no external images) and embed them two-column
beside the text: transmon anharmonic ladder + Rabi drive and the |11>-|02| CZ
avoided crossing (superconducting slide); optical-tweezer array with addressing
beam and the Rydberg blockade (neutral-atom slide). make_slides.py now generates
slides/img/*.png and lays out the platform slides text-left / figures-right.

Co-Authored-By: Claude <noreply@anthropic.com>
</commit_message>
<xml_diff>
--- a/slides/gate_implementations.pptx
+++ b/slides/gate_implementations.pptx
@@ -3098,7 +3098,7 @@
         </p:nvSpPr>
         <p:spPr>
           <a:xfrm>
-            <a:off x="457200" y="274320"/>
+            <a:off x="457200" y="228600"/>
             <a:ext cx="11247120" cy="914400"/>
           </a:xfrm>
           <a:prstGeom prst="rect">
@@ -3113,7 +3113,7 @@
           <a:lstStyle/>
           <a:p>
             <a:r>
-              <a:rPr sz="3000" b="1">
+              <a:rPr sz="2800" b="1">
                 <a:solidFill>
                   <a:srgbClr val="1F3A8A"/>
                 </a:solidFill>
@@ -3123,7 +3123,7 @@
           </a:p>
           <a:p>
             <a:r>
-              <a:rPr sz="1500" i="1">
+              <a:rPr sz="1400" i="1">
                 <a:solidFill>
                   <a:srgbClr val="374151"/>
                 </a:solidFill>
@@ -3142,7 +3142,7 @@
         <p:spPr>
           <a:xfrm>
             <a:off x="457200" y="1234440"/>
-            <a:ext cx="11247120" cy="365760"/>
+            <a:ext cx="6583680" cy="365760"/>
           </a:xfrm>
           <a:prstGeom prst="rect">
             <a:avLst/>
@@ -3156,7 +3156,7 @@
           <a:lstStyle/>
           <a:p>
             <a:r>
-              <a:rPr sz="1700" b="1">
+              <a:rPr sz="1500" b="1">
                 <a:solidFill>
                   <a:srgbClr val="0B603B"/>
                 </a:solidFill>
@@ -3174,8 +3174,8 @@
         </p:nvSpPr>
         <p:spPr>
           <a:xfrm>
-            <a:off x="457200" y="1600200"/>
-            <a:ext cx="11247120" cy="2103120"/>
+            <a:off x="457200" y="1627632"/>
+            <a:ext cx="6583680" cy="2011680"/>
           </a:xfrm>
           <a:prstGeom prst="rect">
             <a:avLst/>
@@ -3194,12 +3194,12 @@
               </a:spcAft>
             </a:pPr>
             <a:r>
-              <a:rPr sz="1500" b="1">
+              <a:rPr sz="1300" b="1">
                 <a:solidFill>
                   <a:srgbClr val="1F3A8A"/>
                 </a:solidFill>
               </a:rPr>
-              <a:t>Qubit = anharmonic LC circuit (transmon); levels |0⟩,|1⟩ set by a microwave drive at ω₀₁.</a:t>
+              <a:t>Qubit = anharmonic LC circuit (transmon); a microwave drive at ω₀₁ addresses |0⟩↔|1⟩.</a:t>
             </a:r>
           </a:p>
           <a:p>
@@ -3209,12 +3209,12 @@
               </a:spcAft>
             </a:pPr>
             <a:r>
-              <a:rPr sz="1500" b="0">
+              <a:rPr sz="1300" b="0">
                 <a:solidFill>
                   <a:srgbClr val="111111"/>
                 </a:solidFill>
               </a:rPr>
-              <a:t>X, Y (π rotations): a shaped, resonant microwave π-pulse drives Rabi flopping; the rotation axis in the x–y plane is chosen by the drive phase (I/Q). Y is X phase-shifted by 90°.</a:t>
+              <a:t>X, Y: a resonant π-pulse drives Rabi flopping; the rotation axis is set by the drive phase (I/Q). Y is X phase-shifted 90°.</a:t>
             </a:r>
           </a:p>
           <a:p>
@@ -3224,12 +3224,12 @@
               </a:spcAft>
             </a:pPr>
             <a:r>
-              <a:rPr sz="1500" b="0">
+              <a:rPr sz="1300" b="0">
                 <a:solidFill>
                   <a:srgbClr val="111111"/>
                 </a:solidFill>
               </a:rPr>
-              <a:t>Z (phase gate): usually a “virtual-Z” — a zero-duration software frame/phase shift of subsequent pulses; alternatively a temporary frequency detuning (flux).</a:t>
+              <a:t>Z: virtual-Z — a zero-duration software phase shift of later pulses (or a brief flux detuning).</a:t>
             </a:r>
           </a:p>
           <a:p>
@@ -3239,12 +3239,12 @@
               </a:spcAft>
             </a:pPr>
             <a:r>
-              <a:rPr sz="1500" b="0">
+              <a:rPr sz="1300" b="0">
                 <a:solidFill>
                   <a:srgbClr val="111111"/>
                 </a:solidFill>
               </a:rPr>
-              <a:t>Hadamard: not native; compiled from the basis {R_z, √X (SX)}, e.g. H = R_z(π/2)·SX·R_z(π/2) (equivalently a π rotation about the (x+z)/√2 axis).</a:t>
+              <a:t>Hadamard: compiled from {R_z, √X}, e.g. H = R_z(π/2)·SX·R_z(π/2).</a:t>
             </a:r>
           </a:p>
         </p:txBody>
@@ -3258,7 +3258,7 @@
         <p:spPr>
           <a:xfrm>
             <a:off x="457200" y="3794760"/>
-            <a:ext cx="11247120" cy="365760"/>
+            <a:ext cx="6583680" cy="365760"/>
           </a:xfrm>
           <a:prstGeom prst="rect">
             <a:avLst/>
@@ -3272,12 +3272,12 @@
           <a:lstStyle/>
           <a:p>
             <a:r>
-              <a:rPr sz="1700" b="1">
+              <a:rPr sz="1500" b="1">
                 <a:solidFill>
                   <a:srgbClr val="0B603B"/>
                 </a:solidFill>
               </a:rPr>
-              <a:t>Two-qubit gate — a tunable interaction imprints a conditional phase</a:t>
+              <a:t>Two-qubit gate — a tunable interaction gives a conditional phase</a:t>
             </a:r>
           </a:p>
         </p:txBody>
@@ -3291,7 +3291,7 @@
         <p:spPr>
           <a:xfrm>
             <a:off x="457200" y="4160520"/>
-            <a:ext cx="11247120" cy="2103120"/>
+            <a:ext cx="6583680" cy="2194560"/>
           </a:xfrm>
           <a:prstGeom prst="rect">
             <a:avLst/>
@@ -3310,12 +3310,12 @@
               </a:spcAft>
             </a:pPr>
             <a:r>
-              <a:rPr sz="1500" b="0">
+              <a:rPr sz="1300" b="0">
                 <a:solidFill>
                   <a:srgbClr val="111111"/>
                 </a:solidFill>
               </a:rPr>
-              <a:t>CZ: flux-tune a qubit (or a tunable coupler) to bring |11⟩ ↔ |02⟩ to an avoided crossing; the conditional π phase realizes controlled-Z.</a:t>
+              <a:t>CZ: flux-tune |11⟩↔|02⟩ to an avoided crossing; the conditional π phase realizes controlled-Z.</a:t>
             </a:r>
           </a:p>
           <a:p>
@@ -3325,12 +3325,12 @@
               </a:spcAft>
             </a:pPr>
             <a:r>
-              <a:rPr sz="1500" b="0">
+              <a:rPr sz="1300" b="0">
                 <a:solidFill>
                   <a:srgbClr val="111111"/>
                 </a:solidFill>
               </a:rPr>
-              <a:t>CNOT: cross-resonance — drive the control qubit at the target's frequency to generate a ZX interaction; an echoed CR pulse plus single-qubit corrections yields CNOT (also CNOT = H·CZ·H).</a:t>
+              <a:t>CNOT: cross-resonance (drive control at target's frequency) → ZX interaction; also CNOT = H·CZ·H.</a:t>
             </a:r>
           </a:p>
           <a:p>
@@ -3340,16 +3340,64 @@
               </a:spcAft>
             </a:pPr>
             <a:r>
-              <a:rPr sz="1500" b="0">
+              <a:rPr sz="1300" b="0">
                 <a:solidFill>
                   <a:srgbClr val="111111"/>
                 </a:solidFill>
               </a:rPr>
-              <a:t>Typical durations: single-qubit ~10–50 ns, two-qubit ~40–300 ns; fidelity limited by T₁/T₂ decoherence and leakage to |2⟩.</a:t>
-            </a:r>
-          </a:p>
-        </p:txBody>
-      </p:sp>
+              <a:t>Times ~10–50 ns (1q), ~40–300 ns (2q); limited by T₁/T₂ and leakage to |2⟩.</a:t>
+            </a:r>
+          </a:p>
+        </p:txBody>
+      </p:sp>
+      <p:pic>
+        <p:nvPicPr>
+          <p:cNvPr id="7" name="Picture 6" descr="sc_1qubit.png"/>
+          <p:cNvPicPr>
+            <a:picLocks noChangeAspect="1"/>
+          </p:cNvPicPr>
+          <p:nvPr/>
+        </p:nvPicPr>
+        <p:blipFill>
+          <a:blip r:embed="rId2"/>
+          <a:stretch>
+            <a:fillRect/>
+          </a:stretch>
+        </p:blipFill>
+        <p:spPr>
+          <a:xfrm>
+            <a:off x="7223760" y="1371600"/>
+            <a:ext cx="4572000" cy="2286000"/>
+          </a:xfrm>
+          <a:prstGeom prst="rect">
+            <a:avLst/>
+          </a:prstGeom>
+        </p:spPr>
+      </p:pic>
+      <p:pic>
+        <p:nvPicPr>
+          <p:cNvPr id="8" name="Picture 7" descr="sc_2qubit.png"/>
+          <p:cNvPicPr>
+            <a:picLocks noChangeAspect="1"/>
+          </p:cNvPicPr>
+          <p:nvPr/>
+        </p:nvPicPr>
+        <p:blipFill>
+          <a:blip r:embed="rId3"/>
+          <a:stretch>
+            <a:fillRect/>
+          </a:stretch>
+        </p:blipFill>
+        <p:spPr>
+          <a:xfrm>
+            <a:off x="7223760" y="3794760"/>
+            <a:ext cx="4572000" cy="2842054"/>
+          </a:xfrm>
+          <a:prstGeom prst="rect">
+            <a:avLst/>
+          </a:prstGeom>
+        </p:spPr>
+      </p:pic>
     </p:spTree>
   </p:cSld>
   <p:clrMapOvr>
@@ -3376,7 +3424,7 @@
         </p:nvSpPr>
         <p:spPr>
           <a:xfrm>
-            <a:off x="457200" y="274320"/>
+            <a:off x="457200" y="228600"/>
             <a:ext cx="11247120" cy="914400"/>
           </a:xfrm>
           <a:prstGeom prst="rect">
@@ -3391,7 +3439,7 @@
           <a:lstStyle/>
           <a:p>
             <a:r>
-              <a:rPr sz="3000" b="1">
+              <a:rPr sz="2800" b="1">
                 <a:solidFill>
                   <a:srgbClr val="1F3A8A"/>
                 </a:solidFill>
@@ -3401,12 +3449,12 @@
           </a:p>
           <a:p>
             <a:r>
-              <a:rPr sz="1500" i="1">
+              <a:rPr sz="1400" i="1">
                 <a:solidFill>
                   <a:srgbClr val="374151"/>
                 </a:solidFill>
               </a:rPr>
-              <a:t>Qubits = two hyperfine ground states of atoms trapped in optical tweezers</a:t>
+              <a:t>Qubits = two hyperfine ground states of atoms in optical tweezers</a:t>
             </a:r>
           </a:p>
         </p:txBody>
@@ -3420,7 +3468,7 @@
         <p:spPr>
           <a:xfrm>
             <a:off x="457200" y="1234440"/>
-            <a:ext cx="11247120" cy="365760"/>
+            <a:ext cx="6583680" cy="365760"/>
           </a:xfrm>
           <a:prstGeom prst="rect">
             <a:avLst/>
@@ -3434,7 +3482,7 @@
           <a:lstStyle/>
           <a:p>
             <a:r>
-              <a:rPr sz="1700" b="1">
+              <a:rPr sz="1500" b="1">
                 <a:solidFill>
                   <a:srgbClr val="0B603B"/>
                 </a:solidFill>
@@ -3452,8 +3500,8 @@
         </p:nvSpPr>
         <p:spPr>
           <a:xfrm>
-            <a:off x="457200" y="1600200"/>
-            <a:ext cx="11247120" cy="2103120"/>
+            <a:off x="457200" y="1627632"/>
+            <a:ext cx="6583680" cy="2011680"/>
           </a:xfrm>
           <a:prstGeom prst="rect">
             <a:avLst/>
@@ -3472,12 +3520,12 @@
               </a:spcAft>
             </a:pPr>
             <a:r>
-              <a:rPr sz="1500" b="1">
+              <a:rPr sz="1300" b="1">
                 <a:solidFill>
                   <a:srgbClr val="1F3A8A"/>
                 </a:solidFill>
               </a:rPr>
-              <a:t>Drive the hyperfine qubit transition with a global microwave field, or with a two-photon optical Raman pair.</a:t>
+              <a:t>Drive the hyperfine qubit with a global microwave field or a two-photon optical Raman pair.</a:t>
             </a:r>
           </a:p>
           <a:p>
@@ -3487,12 +3535,12 @@
               </a:spcAft>
             </a:pPr>
             <a:r>
-              <a:rPr sz="1500" b="0">
+              <a:rPr sz="1300" b="0">
                 <a:solidFill>
                   <a:srgbClr val="111111"/>
                 </a:solidFill>
               </a:rPr>
-              <a:t>X, Y (π rotations): resonant π-pulse; axis set by the drive phase, exactly as for superconducting qubits.</a:t>
+              <a:t>X, Y: resonant π-pulse, axis set by the drive phase (as for transmons); Z by detuning / light shift.</a:t>
             </a:r>
           </a:p>
           <a:p>
@@ -3502,12 +3550,12 @@
               </a:spcAft>
             </a:pPr>
             <a:r>
-              <a:rPr sz="1500" b="0">
+              <a:rPr sz="1300" b="0">
                 <a:solidFill>
                   <a:srgbClr val="111111"/>
                 </a:solidFill>
               </a:rPr>
-              <a:t>Z: detuning or a laser light-shift on the target atom (can be virtual/software).</a:t>
+              <a:t>Hadamard: a π/2 rotation (composition of resonant pulses).</a:t>
             </a:r>
           </a:p>
           <a:p>
@@ -3517,27 +3565,12 @@
               </a:spcAft>
             </a:pPr>
             <a:r>
-              <a:rPr sz="1500" b="0">
+              <a:rPr sz="1300" b="0">
                 <a:solidFill>
                   <a:srgbClr val="111111"/>
                 </a:solidFill>
               </a:rPr>
-              <a:t>Hadamard: a π/2 rotation (composition of resonant pulses).</a:t>
-            </a:r>
-          </a:p>
-          <a:p>
-            <a:pPr>
-              <a:spcAft>
-                <a:spcPts val="300"/>
-              </a:spcAft>
-            </a:pPr>
-            <a:r>
-              <a:rPr sz="1500" b="0">
-                <a:solidFill>
-                  <a:srgbClr val="111111"/>
-                </a:solidFill>
-              </a:rPr>
-              <a:t>Site-resolved single-qubit gates use tightly focused addressing (light-shift) beams to pick out target atoms.</a:t>
+              <a:t>Site-resolved gates use tightly focused addressing (light-shift) beams.</a:t>
             </a:r>
           </a:p>
         </p:txBody>
@@ -3551,7 +3584,7 @@
         <p:spPr>
           <a:xfrm>
             <a:off x="457200" y="3794760"/>
-            <a:ext cx="11247120" cy="365760"/>
+            <a:ext cx="6583680" cy="365760"/>
           </a:xfrm>
           <a:prstGeom prst="rect">
             <a:avLst/>
@@ -3565,7 +3598,7 @@
           <a:lstStyle/>
           <a:p>
             <a:r>
-              <a:rPr sz="1700" b="1">
+              <a:rPr sz="1500" b="1">
                 <a:solidFill>
                   <a:srgbClr val="0B603B"/>
                 </a:solidFill>
@@ -3584,7 +3617,7 @@
         <p:spPr>
           <a:xfrm>
             <a:off x="457200" y="4160520"/>
-            <a:ext cx="11247120" cy="2103120"/>
+            <a:ext cx="6583680" cy="2194560"/>
           </a:xfrm>
           <a:prstGeom prst="rect">
             <a:avLst/>
@@ -3603,12 +3636,12 @@
               </a:spcAft>
             </a:pPr>
             <a:r>
-              <a:rPr sz="1500" b="0">
+              <a:rPr sz="1300" b="0">
                 <a:solidFill>
                   <a:srgbClr val="111111"/>
                 </a:solidFill>
               </a:rPr>
-              <a:t>Excite atoms from |1⟩ to a high-lying Rydberg state |r⟩ with lasers; two nearby Rydberg atoms interact strongly (van der Waals).</a:t>
+              <a:t>Excite |1⟩→|r⟩ (high-lying Rydberg); nearby Rydberg atoms interact strongly (van der Waals).</a:t>
             </a:r>
           </a:p>
           <a:p>
@@ -3618,12 +3651,12 @@
               </a:spcAft>
             </a:pPr>
             <a:r>
-              <a:rPr sz="1500" b="0">
+              <a:rPr sz="1300" b="0">
                 <a:solidFill>
                   <a:srgbClr val="111111"/>
                 </a:solidFill>
               </a:rPr>
-              <a:t>Within the blockade radius R_b, this interaction forbids simultaneous double excitation — the conditional shift realizes CZ (e.g. the Jaksch π–2π–π sequence, or the global two-pulse Levine–Pichler CZ). CNOT = H·CZ·H on the target.</a:t>
+              <a:t>Within blockade radius R_b, double excitation is forbidden — the conditional shift gives CZ (Jaksch π–2π–π, or global Levine–Pichler). CNOT = H·CZ·H.</a:t>
             </a:r>
           </a:p>
           <a:p>
@@ -3633,16 +3666,64 @@
               </a:spcAft>
             </a:pPr>
             <a:r>
-              <a:rPr sz="1500" b="0">
+              <a:rPr sz="1300" b="0">
                 <a:solidFill>
                   <a:srgbClr val="111111"/>
                 </a:solidFill>
               </a:rPr>
-              <a:t>Features: identical qubits, long coherence, reconfigurable connectivity (atoms can be moved); gate times ~ hundreds of ns; Rydberg-state decay is a key error source.</a:t>
-            </a:r>
-          </a:p>
-        </p:txBody>
-      </p:sp>
+              <a:t>Identical qubits, long coherence, movable/reconfigurable connectivity; ~hundreds of ns; Rydberg decay is a key error.</a:t>
+            </a:r>
+          </a:p>
+        </p:txBody>
+      </p:sp>
+      <p:pic>
+        <p:nvPicPr>
+          <p:cNvPr id="7" name="Picture 6" descr="na_1qubit.png"/>
+          <p:cNvPicPr>
+            <a:picLocks noChangeAspect="1"/>
+          </p:cNvPicPr>
+          <p:nvPr/>
+        </p:nvPicPr>
+        <p:blipFill>
+          <a:blip r:embed="rId2"/>
+          <a:stretch>
+            <a:fillRect/>
+          </a:stretch>
+        </p:blipFill>
+        <p:spPr>
+          <a:xfrm>
+            <a:off x="7223760" y="1371600"/>
+            <a:ext cx="4572000" cy="2306688"/>
+          </a:xfrm>
+          <a:prstGeom prst="rect">
+            <a:avLst/>
+          </a:prstGeom>
+        </p:spPr>
+      </p:pic>
+      <p:pic>
+        <p:nvPicPr>
+          <p:cNvPr id="8" name="Picture 7" descr="na_2qubit.png"/>
+          <p:cNvPicPr>
+            <a:picLocks noChangeAspect="1"/>
+          </p:cNvPicPr>
+          <p:nvPr/>
+        </p:nvPicPr>
+        <p:blipFill>
+          <a:blip r:embed="rId3"/>
+          <a:stretch>
+            <a:fillRect/>
+          </a:stretch>
+        </p:blipFill>
+        <p:spPr>
+          <a:xfrm>
+            <a:off x="7223760" y="3794760"/>
+            <a:ext cx="4572000" cy="2634236"/>
+          </a:xfrm>
+          <a:prstGeom prst="rect">
+            <a:avLst/>
+          </a:prstGeom>
+        </p:spPr>
+      </p:pic>
     </p:spTree>
   </p:cSld>
   <p:clrMapOvr>
@@ -3669,7 +3750,7 @@
         </p:nvSpPr>
         <p:spPr>
           <a:xfrm>
-            <a:off x="457200" y="274320"/>
+            <a:off x="457200" y="228600"/>
             <a:ext cx="11247120" cy="914400"/>
           </a:xfrm>
           <a:prstGeom prst="rect">
@@ -3684,7 +3765,7 @@
           <a:lstStyle/>
           <a:p>
             <a:r>
-              <a:rPr sz="3000" b="1">
+              <a:rPr sz="2800" b="1">
                 <a:solidFill>
                   <a:srgbClr val="1F3A8A"/>
                 </a:solidFill>
@@ -3999,7 +4080,7 @@
                   <a:srgbClr val="1F3A8A"/>
                 </a:solidFill>
               </a:rPr>
-              <a:t>Common thread — single-qubit gates: a resonant drive produces Rabi rotations; phase sets the axis (X vs Y), detuning/frame sets Z.</a:t>
+              <a:t>Common thread — single-qubit: a resonant drive gives Rabi rotations; phase sets the axis (X vs Y), detuning/frame sets Z.</a:t>
             </a:r>
           </a:p>
           <a:p>
@@ -4014,7 +4095,7 @@
                   <a:srgbClr val="1F3A8A"/>
                 </a:solidFill>
               </a:rPr>
-              <a:t>Common thread — two-qubit gates: a tunable interaction (avoided crossing, cross-resonance, or Rydberg blockade) imprints a conditional phase, from which CZ/CNOT follow.</a:t>
+              <a:t>Common thread — two-qubit: a tunable interaction (avoided crossing, cross-resonance, or Rydberg blockade) imprints a conditional phase → CZ/CNOT.</a:t>
             </a:r>
           </a:p>
         </p:txBody>

</xml_diff>

<commit_message>
slides: add Chinese speaker notes explaining each gate-implementation slide
Attach Chinese 备注 (notes pane) to all three slides via python-pptx: the
superconducting/transmon slide, the neutral-atom/Rydberg slide, and the comparison
summary. The slides stay English; the notes give a full Chinese walkthrough of the
single- and two-qubit gate mechanisms and the figures.

Co-Authored-By: Claude <noreply@anthropic.com>
</commit_message>
<xml_diff>
--- a/slides/gate_implementations.pptx
+++ b/slides/gate_implementations.pptx
@@ -6,8 +6,8 @@
   </p:sldMasterIdLst>
   <p:sldIdLst>
     <p:sldId id="256" r:id="rId7"/>
-    <p:sldId id="257" r:id="rId8"/>
-    <p:sldId id="258" r:id="rId9"/>
+    <p:sldId id="257" r:id="rId9"/>
+    <p:sldId id="258" r:id="rId10"/>
   </p:sldIdLst>
   <p:sldSz cx="12191695" cy="6858000" type="screen4x3"/>
   <p:notesSz cx="6858000" cy="9144000"/>
@@ -107,6 +107,651 @@
     </a:lvl9pPr>
   </p:defaultTextStyle>
 </p:presentation>
+</file>
+
+<file path=ppt/notesMasters/notesMaster1.xml><?xml version="1.0" encoding="utf-8"?>
+<p:notesMaster xmlns:a="http://schemas.openxmlformats.org/drawingml/2006/main" xmlns:p="http://schemas.openxmlformats.org/presentationml/2006/main" xmlns:r="http://schemas.openxmlformats.org/officeDocument/2006/relationships">
+  <p:cSld>
+    <p:bg>
+      <p:bgRef idx="1001">
+        <a:schemeClr val="bg1"/>
+      </p:bgRef>
+    </p:bg>
+    <p:spTree>
+      <p:nvGrpSpPr>
+        <p:cNvPr id="1" name=""/>
+        <p:cNvGrpSpPr/>
+        <p:nvPr/>
+      </p:nvGrpSpPr>
+      <p:grpSpPr>
+        <a:xfrm>
+          <a:off x="0" y="0"/>
+          <a:ext cx="0" cy="0"/>
+          <a:chOff x="0" y="0"/>
+          <a:chExt cx="0" cy="0"/>
+        </a:xfrm>
+      </p:grpSpPr>
+      <p:sp>
+        <p:nvSpPr>
+          <p:cNvPr id="2" name="Header Placeholder 1"/>
+          <p:cNvSpPr>
+            <a:spLocks noGrp="1"/>
+          </p:cNvSpPr>
+          <p:nvPr>
+            <p:ph type="hdr" sz="quarter"/>
+          </p:nvPr>
+        </p:nvSpPr>
+        <p:spPr>
+          <a:xfrm>
+            <a:off x="0" y="0"/>
+            <a:ext cx="2971800" cy="457200"/>
+          </a:xfrm>
+          <a:prstGeom prst="rect">
+            <a:avLst/>
+          </a:prstGeom>
+        </p:spPr>
+        <p:txBody>
+          <a:bodyPr vert="horz" lIns="91440" tIns="45720" rIns="91440" bIns="45720" rtlCol="0"/>
+          <a:lstStyle>
+            <a:lvl1pPr algn="l">
+              <a:defRPr sz="1200"/>
+            </a:lvl1pPr>
+          </a:lstStyle>
+          <a:p>
+            <a:endParaRPr lang="en-US"/>
+          </a:p>
+        </p:txBody>
+      </p:sp>
+      <p:sp>
+        <p:nvSpPr>
+          <p:cNvPr id="3" name="Date Placeholder 2"/>
+          <p:cNvSpPr>
+            <a:spLocks noGrp="1"/>
+          </p:cNvSpPr>
+          <p:nvPr>
+            <p:ph type="dt" idx="1"/>
+          </p:nvPr>
+        </p:nvSpPr>
+        <p:spPr>
+          <a:xfrm>
+            <a:off x="3884613" y="0"/>
+            <a:ext cx="2971800" cy="457200"/>
+          </a:xfrm>
+          <a:prstGeom prst="rect">
+            <a:avLst/>
+          </a:prstGeom>
+        </p:spPr>
+        <p:txBody>
+          <a:bodyPr vert="horz" lIns="91440" tIns="45720" rIns="91440" bIns="45720" rtlCol="0"/>
+          <a:lstStyle>
+            <a:lvl1pPr algn="r">
+              <a:defRPr sz="1200"/>
+            </a:lvl1pPr>
+          </a:lstStyle>
+          <a:p>
+            <a:fld id="{0F89C1C7-3DCD-1040-A9CF-14679D8B5DDD}" type="datetimeFigureOut">
+              <a:rPr lang="en-US" smtClean="0"/>
+              <a:t>10/17/16</a:t>
+            </a:fld>
+            <a:endParaRPr lang="en-US"/>
+          </a:p>
+        </p:txBody>
+      </p:sp>
+      <p:sp>
+        <p:nvSpPr>
+          <p:cNvPr id="4" name="Slide Image Placeholder 3"/>
+          <p:cNvSpPr>
+            <a:spLocks noGrp="1" noRot="1" noChangeAspect="1"/>
+          </p:cNvSpPr>
+          <p:nvPr>
+            <p:ph type="sldImg" idx="2"/>
+          </p:nvPr>
+        </p:nvSpPr>
+        <p:spPr>
+          <a:xfrm>
+            <a:off x="1143000" y="685800"/>
+            <a:ext cx="4572000" cy="3429000"/>
+          </a:xfrm>
+          <a:prstGeom prst="rect">
+            <a:avLst/>
+          </a:prstGeom>
+          <a:noFill/>
+          <a:ln w="12700">
+            <a:solidFill>
+              <a:prstClr val="black"/>
+            </a:solidFill>
+          </a:ln>
+        </p:spPr>
+        <p:txBody>
+          <a:bodyPr vert="horz" lIns="91440" tIns="45720" rIns="91440" bIns="45720" rtlCol="0" anchor="ctr"/>
+          <a:lstStyle/>
+          <a:p>
+            <a:endParaRPr lang="en-US"/>
+          </a:p>
+        </p:txBody>
+      </p:sp>
+      <p:sp>
+        <p:nvSpPr>
+          <p:cNvPr id="5" name="Notes Placeholder 4"/>
+          <p:cNvSpPr>
+            <a:spLocks noGrp="1"/>
+          </p:cNvSpPr>
+          <p:nvPr>
+            <p:ph type="body" sz="quarter" idx="3"/>
+          </p:nvPr>
+        </p:nvSpPr>
+        <p:spPr>
+          <a:xfrm>
+            <a:off x="685800" y="4343400"/>
+            <a:ext cx="5486400" cy="4114800"/>
+          </a:xfrm>
+          <a:prstGeom prst="rect">
+            <a:avLst/>
+          </a:prstGeom>
+        </p:spPr>
+        <p:txBody>
+          <a:bodyPr vert="horz" lIns="91440" tIns="45720" rIns="91440" bIns="45720" rtlCol="0"/>
+          <a:lstStyle/>
+          <a:p>
+            <a:pPr lvl="0"/>
+            <a:r>
+              <a:rPr lang="en-US" smtClean="0"/>
+              <a:t>Click to edit Master text styles</a:t>
+            </a:r>
+          </a:p>
+          <a:p>
+            <a:pPr lvl="1"/>
+            <a:r>
+              <a:rPr lang="en-US" smtClean="0"/>
+              <a:t>Second level</a:t>
+            </a:r>
+          </a:p>
+          <a:p>
+            <a:pPr lvl="2"/>
+            <a:r>
+              <a:rPr lang="en-US" smtClean="0"/>
+              <a:t>Third level</a:t>
+            </a:r>
+          </a:p>
+          <a:p>
+            <a:pPr lvl="3"/>
+            <a:r>
+              <a:rPr lang="en-US" smtClean="0"/>
+              <a:t>Fourth level</a:t>
+            </a:r>
+          </a:p>
+          <a:p>
+            <a:pPr lvl="4"/>
+            <a:r>
+              <a:rPr lang="en-US" smtClean="0"/>
+              <a:t>Fifth level</a:t>
+            </a:r>
+            <a:endParaRPr lang="en-US"/>
+          </a:p>
+        </p:txBody>
+      </p:sp>
+      <p:sp>
+        <p:nvSpPr>
+          <p:cNvPr id="6" name="Footer Placeholder 5"/>
+          <p:cNvSpPr>
+            <a:spLocks noGrp="1"/>
+          </p:cNvSpPr>
+          <p:nvPr>
+            <p:ph type="ftr" sz="quarter" idx="4"/>
+          </p:nvPr>
+        </p:nvSpPr>
+        <p:spPr>
+          <a:xfrm>
+            <a:off x="0" y="8685213"/>
+            <a:ext cx="2971800" cy="457200"/>
+          </a:xfrm>
+          <a:prstGeom prst="rect">
+            <a:avLst/>
+          </a:prstGeom>
+        </p:spPr>
+        <p:txBody>
+          <a:bodyPr vert="horz" lIns="91440" tIns="45720" rIns="91440" bIns="45720" rtlCol="0" anchor="b"/>
+          <a:lstStyle>
+            <a:lvl1pPr algn="l">
+              <a:defRPr sz="1200"/>
+            </a:lvl1pPr>
+          </a:lstStyle>
+          <a:p>
+            <a:endParaRPr lang="en-US"/>
+          </a:p>
+        </p:txBody>
+      </p:sp>
+      <p:sp>
+        <p:nvSpPr>
+          <p:cNvPr id="7" name="Slide Number Placeholder 6"/>
+          <p:cNvSpPr>
+            <a:spLocks noGrp="1"/>
+          </p:cNvSpPr>
+          <p:nvPr>
+            <p:ph type="sldNum" sz="quarter" idx="5"/>
+          </p:nvPr>
+        </p:nvSpPr>
+        <p:spPr>
+          <a:xfrm>
+            <a:off x="3884613" y="8685213"/>
+            <a:ext cx="2971800" cy="457200"/>
+          </a:xfrm>
+          <a:prstGeom prst="rect">
+            <a:avLst/>
+          </a:prstGeom>
+        </p:spPr>
+        <p:txBody>
+          <a:bodyPr vert="horz" lIns="91440" tIns="45720" rIns="91440" bIns="45720" rtlCol="0" anchor="b"/>
+          <a:lstStyle>
+            <a:lvl1pPr algn="r">
+              <a:defRPr sz="1200"/>
+            </a:lvl1pPr>
+          </a:lstStyle>
+          <a:p>
+            <a:fld id="{BB5E49A5-4136-284D-997B-48E1D791AD67}" type="slidenum">
+              <a:rPr lang="en-US" smtClean="0"/>
+              <a:t>‹#›</a:t>
+            </a:fld>
+            <a:endParaRPr lang="en-US"/>
+          </a:p>
+        </p:txBody>
+      </p:sp>
+    </p:spTree>
+    <p:extLst>
+      <p:ext uri="{BB962C8B-B14F-4D97-AF65-F5344CB8AC3E}">
+        <p14:creationId xmlns:p14="http://schemas.microsoft.com/office/powerpoint/2010/main" val="2623252185"/>
+      </p:ext>
+    </p:extLst>
+  </p:cSld>
+  <p:clrMap bg1="lt1" tx1="dk1" bg2="lt2" tx2="dk2" accent1="accent1" accent2="accent2" accent3="accent3" accent4="accent4" accent5="accent5" accent6="accent6" hlink="hlink" folHlink="folHlink"/>
+  <p:notesStyle>
+    <a:lvl1pPr marL="0" algn="l" defTabSz="457200" rtl="0" eaLnBrk="1" latinLnBrk="0" hangingPunct="1">
+      <a:defRPr sz="1200" kern="1200">
+        <a:solidFill>
+          <a:schemeClr val="tx1"/>
+        </a:solidFill>
+        <a:latin typeface="+mn-lt"/>
+        <a:ea typeface="+mn-ea"/>
+        <a:cs typeface="+mn-cs"/>
+      </a:defRPr>
+    </a:lvl1pPr>
+    <a:lvl2pPr marL="457200" algn="l" defTabSz="457200" rtl="0" eaLnBrk="1" latinLnBrk="0" hangingPunct="1">
+      <a:defRPr sz="1200" kern="1200">
+        <a:solidFill>
+          <a:schemeClr val="tx1"/>
+        </a:solidFill>
+        <a:latin typeface="+mn-lt"/>
+        <a:ea typeface="+mn-ea"/>
+        <a:cs typeface="+mn-cs"/>
+      </a:defRPr>
+    </a:lvl2pPr>
+    <a:lvl3pPr marL="914400" algn="l" defTabSz="457200" rtl="0" eaLnBrk="1" latinLnBrk="0" hangingPunct="1">
+      <a:defRPr sz="1200" kern="1200">
+        <a:solidFill>
+          <a:schemeClr val="tx1"/>
+        </a:solidFill>
+        <a:latin typeface="+mn-lt"/>
+        <a:ea typeface="+mn-ea"/>
+        <a:cs typeface="+mn-cs"/>
+      </a:defRPr>
+    </a:lvl3pPr>
+    <a:lvl4pPr marL="1371600" algn="l" defTabSz="457200" rtl="0" eaLnBrk="1" latinLnBrk="0" hangingPunct="1">
+      <a:defRPr sz="1200" kern="1200">
+        <a:solidFill>
+          <a:schemeClr val="tx1"/>
+        </a:solidFill>
+        <a:latin typeface="+mn-lt"/>
+        <a:ea typeface="+mn-ea"/>
+        <a:cs typeface="+mn-cs"/>
+      </a:defRPr>
+    </a:lvl4pPr>
+    <a:lvl5pPr marL="1828800" algn="l" defTabSz="457200" rtl="0" eaLnBrk="1" latinLnBrk="0" hangingPunct="1">
+      <a:defRPr sz="1200" kern="1200">
+        <a:solidFill>
+          <a:schemeClr val="tx1"/>
+        </a:solidFill>
+        <a:latin typeface="+mn-lt"/>
+        <a:ea typeface="+mn-ea"/>
+        <a:cs typeface="+mn-cs"/>
+      </a:defRPr>
+    </a:lvl5pPr>
+    <a:lvl6pPr marL="2286000" algn="l" defTabSz="457200" rtl="0" eaLnBrk="1" latinLnBrk="0" hangingPunct="1">
+      <a:defRPr sz="1200" kern="1200">
+        <a:solidFill>
+          <a:schemeClr val="tx1"/>
+        </a:solidFill>
+        <a:latin typeface="+mn-lt"/>
+        <a:ea typeface="+mn-ea"/>
+        <a:cs typeface="+mn-cs"/>
+      </a:defRPr>
+    </a:lvl6pPr>
+    <a:lvl7pPr marL="2743200" algn="l" defTabSz="457200" rtl="0" eaLnBrk="1" latinLnBrk="0" hangingPunct="1">
+      <a:defRPr sz="1200" kern="1200">
+        <a:solidFill>
+          <a:schemeClr val="tx1"/>
+        </a:solidFill>
+        <a:latin typeface="+mn-lt"/>
+        <a:ea typeface="+mn-ea"/>
+        <a:cs typeface="+mn-cs"/>
+      </a:defRPr>
+    </a:lvl7pPr>
+    <a:lvl8pPr marL="3200400" algn="l" defTabSz="457200" rtl="0" eaLnBrk="1" latinLnBrk="0" hangingPunct="1">
+      <a:defRPr sz="1200" kern="1200">
+        <a:solidFill>
+          <a:schemeClr val="tx1"/>
+        </a:solidFill>
+        <a:latin typeface="+mn-lt"/>
+        <a:ea typeface="+mn-ea"/>
+        <a:cs typeface="+mn-cs"/>
+      </a:defRPr>
+    </a:lvl8pPr>
+    <a:lvl9pPr marL="3657600" algn="l" defTabSz="457200" rtl="0" eaLnBrk="1" latinLnBrk="0" hangingPunct="1">
+      <a:defRPr sz="1200" kern="1200">
+        <a:solidFill>
+          <a:schemeClr val="tx1"/>
+        </a:solidFill>
+        <a:latin typeface="+mn-lt"/>
+        <a:ea typeface="+mn-ea"/>
+        <a:cs typeface="+mn-cs"/>
+      </a:defRPr>
+    </a:lvl9pPr>
+  </p:notesStyle>
+</p:notesMaster>
+</file>
+
+<file path=ppt/notesSlides/notesSlide1.xml><?xml version="1.0" encoding="utf-8"?>
+<p:notes xmlns:a="http://schemas.openxmlformats.org/drawingml/2006/main" xmlns:p="http://schemas.openxmlformats.org/presentationml/2006/main" xmlns:r="http://schemas.openxmlformats.org/officeDocument/2006/relationships">
+  <p:cSld>
+    <p:spTree>
+      <p:nvGrpSpPr>
+        <p:cNvPr id="1" name=""/>
+        <p:cNvGrpSpPr/>
+        <p:nvPr/>
+      </p:nvGrpSpPr>
+      <p:grpSpPr>
+        <a:xfrm>
+          <a:off x="0" y="0"/>
+          <a:ext cx="0" cy="0"/>
+          <a:chOff x="0" y="0"/>
+          <a:chExt cx="0" cy="0"/>
+        </a:xfrm>
+      </p:grpSpPr>
+      <p:sp>
+        <p:nvSpPr>
+          <p:cNvPr id="2" name="Slide Image Placeholder 1"/>
+          <p:cNvSpPr>
+            <a:spLocks noGrp="1"/>
+          </p:cNvSpPr>
+          <p:nvPr>
+            <p:ph type="sldImg" idx="2"/>
+          </p:nvPr>
+        </p:nvSpPr>
+        <p:spPr/>
+      </p:sp>
+      <p:sp>
+        <p:nvSpPr>
+          <p:cNvPr id="3" name="Notes Placeholder 2"/>
+          <p:cNvSpPr>
+            <a:spLocks noGrp="1"/>
+          </p:cNvSpPr>
+          <p:nvPr>
+            <p:ph type="body" idx="3" sz="quarter"/>
+          </p:nvPr>
+        </p:nvSpPr>
+        <p:spPr/>
+        <p:txBody>
+          <a:bodyPr/>
+          <a:lstStyle/>
+          <a:p>
+            <a:r>
+              <a:t>【超导量子比特（transmon 传输子）】</a:t>
+            </a:r>
+          </a:p>
+          <a:p>
+            <a:r>
+              <a:t>· 量子比特是一个非谐振荡器：电容与约瑟夫森结并联。用频率 ω01 的微波脉冲驱动 |0⟩↔|1⟩。因为能级不等间距（ω12 ≠ ω01），可只驱动 |0⟩-|1⟩ 而不泄漏到 |2⟩。</a:t>
+            </a:r>
+          </a:p>
+          <a:p>
+            <a:r>
+              <a:t>· 单比特门 X、Y：共振 π 脉冲产生拉比（Rabi）振荡；旋转轴由驱动相位（I/Q）决定，Y 即 X 相移 90°。</a:t>
+            </a:r>
+          </a:p>
+          <a:p>
+            <a:r>
+              <a:t>· Z 门：常用“虚拟 Z”——对后续脉冲做零时长的软件相位平移；或用磁通短暂失谐。</a:t>
+            </a:r>
+          </a:p>
+          <a:p>
+            <a:r>
+              <a:t>· Hadamard 非原生门，由 {R_z, √X} 编译，例如 H = R_z(π/2)·SX·R_z(π/2)。</a:t>
+            </a:r>
+          </a:p>
+          <a:p>
+            <a:r>
+              <a:t>· 两比特 CZ：调节磁通/可调耦合器，使 |11⟩ 与 |02⟩ 到达“避免交叉”，得到的条件 π 相位即受控 Z；CNOT 可用交叉共振，或 H·CZ·H。</a:t>
+            </a:r>
+          </a:p>
+          <a:p>
+            <a:r>
+              <a:t>· 典型门时间：单比特约 10–50 ns，两比特约 40–300 ns；主要受 T1/T2 退相干与向 |2⟩ 泄漏限制。</a:t>
+            </a:r>
+          </a:p>
+          <a:p>
+            <a:r>
+              <a:t>· 左图：非谐势阱中的能级与微波驱动。右图：CZ 的避免交叉。</a:t>
+            </a:r>
+          </a:p>
+        </p:txBody>
+      </p:sp>
+      <p:sp>
+        <p:nvSpPr>
+          <p:cNvPr id="4" name="Slide Number Placeholder 3"/>
+          <p:cNvSpPr>
+            <a:spLocks noGrp="1"/>
+          </p:cNvSpPr>
+          <p:nvPr>
+            <p:ph type="sldNum" idx="5" sz="quarter"/>
+          </p:nvPr>
+        </p:nvSpPr>
+        <p:spPr/>
+      </p:sp>
+    </p:spTree>
+  </p:cSld>
+  <p:clrMapOvr>
+    <a:masterClrMapping/>
+  </p:clrMapOvr>
+</p:notes>
+</file>
+
+<file path=ppt/notesSlides/notesSlide2.xml><?xml version="1.0" encoding="utf-8"?>
+<p:notes xmlns:a="http://schemas.openxmlformats.org/drawingml/2006/main" xmlns:p="http://schemas.openxmlformats.org/presentationml/2006/main" xmlns:r="http://schemas.openxmlformats.org/officeDocument/2006/relationships">
+  <p:cSld>
+    <p:spTree>
+      <p:nvGrpSpPr>
+        <p:cNvPr id="1" name=""/>
+        <p:cNvGrpSpPr/>
+        <p:nvPr/>
+      </p:nvGrpSpPr>
+      <p:grpSpPr>
+        <a:xfrm>
+          <a:off x="0" y="0"/>
+          <a:ext cx="0" cy="0"/>
+          <a:chOff x="0" y="0"/>
+          <a:chExt cx="0" cy="0"/>
+        </a:xfrm>
+      </p:grpSpPr>
+      <p:sp>
+        <p:nvSpPr>
+          <p:cNvPr id="2" name="Slide Image Placeholder 1"/>
+          <p:cNvSpPr>
+            <a:spLocks noGrp="1"/>
+          </p:cNvSpPr>
+          <p:nvPr>
+            <p:ph type="sldImg" idx="2"/>
+          </p:nvPr>
+        </p:nvSpPr>
+        <p:spPr/>
+      </p:sp>
+      <p:sp>
+        <p:nvSpPr>
+          <p:cNvPr id="3" name="Notes Placeholder 2"/>
+          <p:cNvSpPr>
+            <a:spLocks noGrp="1"/>
+          </p:cNvSpPr>
+          <p:nvPr>
+            <p:ph type="body" idx="3" sz="quarter"/>
+          </p:nvPr>
+        </p:nvSpPr>
+        <p:spPr/>
+        <p:txBody>
+          <a:bodyPr/>
+          <a:lstStyle/>
+          <a:p>
+            <a:r>
+              <a:t>【中性原子（里德堡阵列）】</a:t>
+            </a:r>
+          </a:p>
+          <a:p>
+            <a:r>
+              <a:t>· 量子比特 = 光镊（optical tweezers）中原子的两个超精细基态 |0⟩、|1⟩。</a:t>
+            </a:r>
+          </a:p>
+          <a:p>
+            <a:r>
+              <a:t>· 单比特门：用全局微波场或双光子拉曼（Raman）对驱动比特跃迁。X、Y 为共振 π 脉冲，轴由驱动相位决定（与超导相同）；Z 用失谐或光频移（可做成虚拟 Z）。</a:t>
+            </a:r>
+          </a:p>
+          <a:p>
+            <a:r>
+              <a:t>· 位点选址：用紧聚焦的寻址（光频移）光束单独作用于目标原子，实现单比特寻址门。</a:t>
+            </a:r>
+          </a:p>
+          <a:p>
+            <a:r>
+              <a:t>· 两比特 CZ：里德堡阻塞（Rydberg blockade）。用激光把 |1⟩ 激发到高里德堡态 |r⟩；阻塞半径 R_b 内两原子的范德瓦尔斯相互作用很强，禁止同时双激发（|rr⟩ 被移出共振），由此条件相移得到 CZ（如 Jaksch π–2π–π，或全局的 Levine–Pichler 方案）；CNOT = H·CZ·H。</a:t>
+            </a:r>
+          </a:p>
+          <a:p>
+            <a:r>
+              <a:t>· 特点：比特全同、相干时间长、连接可重构（原子可移动）；门时间约数百 ns；里德堡态衰变是主要误差源。</a:t>
+            </a:r>
+          </a:p>
+          <a:p>
+            <a:r>
+              <a:t>· 左图：光镊阵列与寻址光束。右图：里德堡阻塞。</a:t>
+            </a:r>
+          </a:p>
+        </p:txBody>
+      </p:sp>
+      <p:sp>
+        <p:nvSpPr>
+          <p:cNvPr id="4" name="Slide Number Placeholder 3"/>
+          <p:cNvSpPr>
+            <a:spLocks noGrp="1"/>
+          </p:cNvSpPr>
+          <p:nvPr>
+            <p:ph type="sldNum" idx="5" sz="quarter"/>
+          </p:nvPr>
+        </p:nvSpPr>
+        <p:spPr/>
+      </p:sp>
+    </p:spTree>
+  </p:cSld>
+  <p:clrMapOvr>
+    <a:masterClrMapping/>
+  </p:clrMapOvr>
+</p:notes>
+</file>
+
+<file path=ppt/notesSlides/notesSlide3.xml><?xml version="1.0" encoding="utf-8"?>
+<p:notes xmlns:a="http://schemas.openxmlformats.org/drawingml/2006/main" xmlns:p="http://schemas.openxmlformats.org/presentationml/2006/main" xmlns:r="http://schemas.openxmlformats.org/officeDocument/2006/relationships">
+  <p:cSld>
+    <p:spTree>
+      <p:nvGrpSpPr>
+        <p:cNvPr id="1" name=""/>
+        <p:cNvGrpSpPr/>
+        <p:nvPr/>
+      </p:nvGrpSpPr>
+      <p:grpSpPr>
+        <a:xfrm>
+          <a:off x="0" y="0"/>
+          <a:ext cx="0" cy="0"/>
+          <a:chOff x="0" y="0"/>
+          <a:chExt cx="0" cy="0"/>
+        </a:xfrm>
+      </p:grpSpPr>
+      <p:sp>
+        <p:nvSpPr>
+          <p:cNvPr id="2" name="Slide Image Placeholder 1"/>
+          <p:cNvSpPr>
+            <a:spLocks noGrp="1"/>
+          </p:cNvSpPr>
+          <p:nvPr>
+            <p:ph type="sldImg" idx="2"/>
+          </p:nvPr>
+        </p:nvSpPr>
+        <p:spPr/>
+      </p:sp>
+      <p:sp>
+        <p:nvSpPr>
+          <p:cNvPr id="3" name="Notes Placeholder 2"/>
+          <p:cNvSpPr>
+            <a:spLocks noGrp="1"/>
+          </p:cNvSpPr>
+          <p:nvPr>
+            <p:ph type="body" idx="3" sz="quarter"/>
+          </p:nvPr>
+        </p:nvSpPr>
+        <p:spPr/>
+        <p:txBody>
+          <a:bodyPr/>
+          <a:lstStyle/>
+          <a:p>
+            <a:r>
+              <a:t>【小结：同一原理，不同硬件“旋钮”】</a:t>
+            </a:r>
+          </a:p>
+          <a:p>
+            <a:r>
+              <a:t>· 单比特门的共同点：一个共振驱动产生拉比旋转；相位设定旋转轴（X 对 Y），失谐/参考系设定 Z。</a:t>
+            </a:r>
+          </a:p>
+          <a:p>
+            <a:r>
+              <a:t>· 两比特门的共同点：一个可调相互作用（避免交叉、交叉共振、或里德堡阻塞）施加条件相位，由此得到 CZ/CNOT。</a:t>
+            </a:r>
+          </a:p>
+          <a:p>
+            <a:r>
+              <a:t>· 区别只在实现的“旋钮”不同：超导用磁通/可调耦合器/交叉共振；中性原子用里德堡阻塞。</a:t>
+            </a:r>
+          </a:p>
+          <a:p>
+            <a:r>
+              <a:t>· 表格逐行对照 X/Y、Z、Hadamard、两比特门在两个平台上的实现方式。</a:t>
+            </a:r>
+          </a:p>
+        </p:txBody>
+      </p:sp>
+      <p:sp>
+        <p:nvSpPr>
+          <p:cNvPr id="4" name="Slide Number Placeholder 3"/>
+          <p:cNvSpPr>
+            <a:spLocks noGrp="1"/>
+          </p:cNvSpPr>
+          <p:nvPr>
+            <p:ph type="sldNum" idx="5" sz="quarter"/>
+          </p:nvPr>
+        </p:nvSpPr>
+        <p:spPr/>
+      </p:sp>
+    </p:spTree>
+  </p:cSld>
+  <p:clrMapOvr>
+    <a:masterClrMapping/>
+  </p:clrMapOvr>
+</p:notes>
 </file>
 
 <file path=ppt/slideLayouts/slideLayout1.xml><?xml version="1.0" encoding="utf-8"?>
@@ -4426,4 +5071,324 @@
   </a:objectDefaults>
   <a:extraClrSchemeLst/>
 </a:theme>
+</file>
+
+<file path=ppt/theme/theme2.xml><?xml version="1.0" encoding="utf-8"?>
+<a:theme xmlns:a="http://schemas.openxmlformats.org/drawingml/2006/main" name="Office Theme">
+  <a:themeElements>
+    <a:clrScheme name="Office">
+      <a:dk1>
+        <a:sysClr val="windowText" lastClr="000000"/>
+      </a:dk1>
+      <a:lt1>
+        <a:sysClr val="window" lastClr="FFFFFF"/>
+      </a:lt1>
+      <a:dk2>
+        <a:srgbClr val="1F497D"/>
+      </a:dk2>
+      <a:lt2>
+        <a:srgbClr val="EEECE1"/>
+      </a:lt2>
+      <a:accent1>
+        <a:srgbClr val="4F81BD"/>
+      </a:accent1>
+      <a:accent2>
+        <a:srgbClr val="C0504D"/>
+      </a:accent2>
+      <a:accent3>
+        <a:srgbClr val="9BBB59"/>
+      </a:accent3>
+      <a:accent4>
+        <a:srgbClr val="8064A2"/>
+      </a:accent4>
+      <a:accent5>
+        <a:srgbClr val="4BACC6"/>
+      </a:accent5>
+      <a:accent6>
+        <a:srgbClr val="F79646"/>
+      </a:accent6>
+      <a:hlink>
+        <a:srgbClr val="0000FF"/>
+      </a:hlink>
+      <a:folHlink>
+        <a:srgbClr val="800080"/>
+      </a:folHlink>
+    </a:clrScheme>
+    <a:fontScheme name="Office">
+      <a:majorFont>
+        <a:latin typeface="Calibri"/>
+        <a:ea typeface=""/>
+        <a:cs typeface=""/>
+        <a:font script="Jpan" typeface="ＭＳ Ｐゴシック"/>
+        <a:font script="Hang" typeface="맑은 고딕"/>
+        <a:font script="Hans" typeface="宋体"/>
+        <a:font script="Hant" typeface="新細明體"/>
+        <a:font script="Arab" typeface="Times New Roman"/>
+        <a:font script="Hebr" typeface="Times New Roman"/>
+        <a:font script="Thai" typeface="Angsana New"/>
+        <a:font script="Ethi" typeface="Nyala"/>
+        <a:font script="Beng" typeface="Vrinda"/>
+        <a:font script="Gujr" typeface="Shruti"/>
+        <a:font script="Khmr" typeface="MoolBoran"/>
+        <a:font script="Knda" typeface="Tunga"/>
+        <a:font script="Guru" typeface="Raavi"/>
+        <a:font script="Cans" typeface="Euphemia"/>
+        <a:font script="Cher" typeface="Plantagenet Cherokee"/>
+        <a:font script="Yiii" typeface="Microsoft Yi Baiti"/>
+        <a:font script="Tibt" typeface="Microsoft Himalaya"/>
+        <a:font script="Thaa" typeface="MV Boli"/>
+        <a:font script="Deva" typeface="Mangal"/>
+        <a:font script="Telu" typeface="Gautami"/>
+        <a:font script="Taml" typeface="Latha"/>
+        <a:font script="Syrc" typeface="Estrangelo Edessa"/>
+        <a:font script="Orya" typeface="Kalinga"/>
+        <a:font script="Mlym" typeface="Kartika"/>
+        <a:font script="Laoo" typeface="DokChampa"/>
+        <a:font script="Sinh" typeface="Iskoola Pota"/>
+        <a:font script="Mong" typeface="Mongolian Baiti"/>
+        <a:font script="Viet" typeface="Times New Roman"/>
+        <a:font script="Uigh" typeface="Microsoft Uighur"/>
+        <a:font script="Geor" typeface="Sylfaen"/>
+      </a:majorFont>
+      <a:minorFont>
+        <a:latin typeface="Calibri"/>
+        <a:ea typeface=""/>
+        <a:cs typeface=""/>
+        <a:font script="Jpan" typeface="ＭＳ Ｐゴシック"/>
+        <a:font script="Hang" typeface="맑은 고딕"/>
+        <a:font script="Hans" typeface="宋体"/>
+        <a:font script="Hant" typeface="新細明體"/>
+        <a:font script="Arab" typeface="Arial"/>
+        <a:font script="Hebr" typeface="Arial"/>
+        <a:font script="Thai" typeface="Cordia New"/>
+        <a:font script="Ethi" typeface="Nyala"/>
+        <a:font script="Beng" typeface="Vrinda"/>
+        <a:font script="Gujr" typeface="Shruti"/>
+        <a:font script="Khmr" typeface="DaunPenh"/>
+        <a:font script="Knda" typeface="Tunga"/>
+        <a:font script="Guru" typeface="Raavi"/>
+        <a:font script="Cans" typeface="Euphemia"/>
+        <a:font script="Cher" typeface="Plantagenet Cherokee"/>
+        <a:font script="Yiii" typeface="Microsoft Yi Baiti"/>
+        <a:font script="Tibt" typeface="Microsoft Himalaya"/>
+        <a:font script="Thaa" typeface="MV Boli"/>
+        <a:font script="Deva" typeface="Mangal"/>
+        <a:font script="Telu" typeface="Gautami"/>
+        <a:font script="Taml" typeface="Latha"/>
+        <a:font script="Syrc" typeface="Estrangelo Edessa"/>
+        <a:font script="Orya" typeface="Kalinga"/>
+        <a:font script="Mlym" typeface="Kartika"/>
+        <a:font script="Laoo" typeface="DokChampa"/>
+        <a:font script="Sinh" typeface="Iskoola Pota"/>
+        <a:font script="Mong" typeface="Mongolian Baiti"/>
+        <a:font script="Viet" typeface="Arial"/>
+        <a:font script="Uigh" typeface="Microsoft Uighur"/>
+        <a:font script="Geor" typeface="Sylfaen"/>
+      </a:minorFont>
+    </a:fontScheme>
+    <a:fmtScheme name="Office">
+      <a:fillStyleLst>
+        <a:solidFill>
+          <a:schemeClr val="phClr"/>
+        </a:solidFill>
+        <a:gradFill rotWithShape="1">
+          <a:gsLst>
+            <a:gs pos="0">
+              <a:schemeClr val="phClr">
+                <a:tint val="50000"/>
+                <a:satMod val="300000"/>
+              </a:schemeClr>
+            </a:gs>
+            <a:gs pos="35000">
+              <a:schemeClr val="phClr">
+                <a:tint val="37000"/>
+                <a:satMod val="300000"/>
+              </a:schemeClr>
+            </a:gs>
+            <a:gs pos="100000">
+              <a:schemeClr val="phClr">
+                <a:tint val="15000"/>
+                <a:satMod val="350000"/>
+              </a:schemeClr>
+            </a:gs>
+          </a:gsLst>
+          <a:lin ang="16200000" scaled="1"/>
+        </a:gradFill>
+        <a:gradFill rotWithShape="1">
+          <a:gsLst>
+            <a:gs pos="0">
+              <a:schemeClr val="phClr">
+                <a:tint val="100000"/>
+                <a:shade val="100000"/>
+                <a:satMod val="130000"/>
+              </a:schemeClr>
+            </a:gs>
+            <a:gs pos="100000">
+              <a:schemeClr val="phClr">
+                <a:tint val="50000"/>
+                <a:shade val="100000"/>
+                <a:satMod val="350000"/>
+              </a:schemeClr>
+            </a:gs>
+          </a:gsLst>
+          <a:lin ang="16200000" scaled="0"/>
+        </a:gradFill>
+      </a:fillStyleLst>
+      <a:lnStyleLst>
+        <a:ln w="9525" cap="flat" cmpd="sng" algn="ctr">
+          <a:solidFill>
+            <a:schemeClr val="phClr">
+              <a:shade val="95000"/>
+              <a:satMod val="105000"/>
+            </a:schemeClr>
+          </a:solidFill>
+          <a:prstDash val="solid"/>
+        </a:ln>
+        <a:ln w="25400" cap="flat" cmpd="sng" algn="ctr">
+          <a:solidFill>
+            <a:schemeClr val="phClr"/>
+          </a:solidFill>
+          <a:prstDash val="solid"/>
+        </a:ln>
+        <a:ln w="38100" cap="flat" cmpd="sng" algn="ctr">
+          <a:solidFill>
+            <a:schemeClr val="phClr"/>
+          </a:solidFill>
+          <a:prstDash val="solid"/>
+        </a:ln>
+      </a:lnStyleLst>
+      <a:effectStyleLst>
+        <a:effectStyle>
+          <a:effectLst>
+            <a:outerShdw blurRad="40000" dist="20000" dir="5400000" rotWithShape="0">
+              <a:srgbClr val="000000">
+                <a:alpha val="38000"/>
+              </a:srgbClr>
+            </a:outerShdw>
+          </a:effectLst>
+        </a:effectStyle>
+        <a:effectStyle>
+          <a:effectLst>
+            <a:outerShdw blurRad="40000" dist="23000" dir="5400000" rotWithShape="0">
+              <a:srgbClr val="000000">
+                <a:alpha val="35000"/>
+              </a:srgbClr>
+            </a:outerShdw>
+          </a:effectLst>
+        </a:effectStyle>
+        <a:effectStyle>
+          <a:effectLst>
+            <a:outerShdw blurRad="40000" dist="23000" dir="5400000" rotWithShape="0">
+              <a:srgbClr val="000000">
+                <a:alpha val="35000"/>
+              </a:srgbClr>
+            </a:outerShdw>
+          </a:effectLst>
+          <a:scene3d>
+            <a:camera prst="orthographicFront">
+              <a:rot lat="0" lon="0" rev="0"/>
+            </a:camera>
+            <a:lightRig rig="threePt" dir="t">
+              <a:rot lat="0" lon="0" rev="1200000"/>
+            </a:lightRig>
+          </a:scene3d>
+          <a:sp3d>
+            <a:bevelT w="63500" h="25400"/>
+          </a:sp3d>
+        </a:effectStyle>
+      </a:effectStyleLst>
+      <a:bgFillStyleLst>
+        <a:solidFill>
+          <a:schemeClr val="phClr"/>
+        </a:solidFill>
+        <a:gradFill rotWithShape="1">
+          <a:gsLst>
+            <a:gs pos="0">
+              <a:schemeClr val="phClr">
+                <a:tint val="40000"/>
+                <a:satMod val="350000"/>
+              </a:schemeClr>
+            </a:gs>
+            <a:gs pos="40000">
+              <a:schemeClr val="phClr">
+                <a:tint val="45000"/>
+                <a:shade val="99000"/>
+                <a:satMod val="350000"/>
+              </a:schemeClr>
+            </a:gs>
+            <a:gs pos="100000">
+              <a:schemeClr val="phClr">
+                <a:shade val="20000"/>
+                <a:satMod val="255000"/>
+              </a:schemeClr>
+            </a:gs>
+          </a:gsLst>
+          <a:path path="circle">
+            <a:fillToRect l="50000" t="-80000" r="50000" b="180000"/>
+          </a:path>
+        </a:gradFill>
+        <a:gradFill rotWithShape="1">
+          <a:gsLst>
+            <a:gs pos="0">
+              <a:schemeClr val="phClr">
+                <a:tint val="80000"/>
+                <a:satMod val="300000"/>
+              </a:schemeClr>
+            </a:gs>
+            <a:gs pos="100000">
+              <a:schemeClr val="phClr">
+                <a:shade val="30000"/>
+                <a:satMod val="200000"/>
+              </a:schemeClr>
+            </a:gs>
+          </a:gsLst>
+          <a:path path="circle">
+            <a:fillToRect l="50000" t="50000" r="50000" b="50000"/>
+          </a:path>
+        </a:gradFill>
+      </a:bgFillStyleLst>
+    </a:fmtScheme>
+  </a:themeElements>
+  <a:objectDefaults>
+    <a:spDef>
+      <a:spPr/>
+      <a:bodyPr/>
+      <a:lstStyle/>
+      <a:style>
+        <a:lnRef idx="1">
+          <a:schemeClr val="accent1"/>
+        </a:lnRef>
+        <a:fillRef idx="3">
+          <a:schemeClr val="accent1"/>
+        </a:fillRef>
+        <a:effectRef idx="2">
+          <a:schemeClr val="accent1"/>
+        </a:effectRef>
+        <a:fontRef idx="minor">
+          <a:schemeClr val="lt1"/>
+        </a:fontRef>
+      </a:style>
+    </a:spDef>
+    <a:lnDef>
+      <a:spPr/>
+      <a:bodyPr/>
+      <a:lstStyle/>
+      <a:style>
+        <a:lnRef idx="2">
+          <a:schemeClr val="accent1"/>
+        </a:lnRef>
+        <a:fillRef idx="0">
+          <a:schemeClr val="accent1"/>
+        </a:fillRef>
+        <a:effectRef idx="1">
+          <a:schemeClr val="accent1"/>
+        </a:effectRef>
+        <a:fontRef idx="minor">
+          <a:schemeClr val="tx1"/>
+        </a:fontRef>
+      </a:style>
+    </a:lnDef>
+  </a:objectDefaults>
+  <a:extraClrSchemeLst/>
+</a:theme>
 </file>
</xml_diff>